<commit_message>
Publish 145060 as an 18-week course with no calendar dates
</commit_message>
<xml_diff>
--- a/Courses/145060/units/unit-00-onboarding/04-slides/exports/MCCTC_145060_Slides_W01_CommitsAndHistory.pptx
+++ b/Courses/145060/units/unit-00-onboarding/04-slides/exports/MCCTC_145060_Slides_W01_CommitsAndHistory.pptx
@@ -28,24 +28,12 @@
       <p:regular r:id="rId201314"/>
     </p:embeddedFont>
     <p:embeddedFont>
-      <p:font typeface="Orbitron"/>
+      <p:font typeface="Roboto Condensed Bold"/>
       <p:regular r:id="rId201315"/>
     </p:embeddedFont>
     <p:embeddedFont>
-      <p:font typeface="Orbitron Black"/>
+      <p:font typeface="Roboto Condensed"/>
       <p:regular r:id="rId201316"/>
-    </p:embeddedFont>
-    <p:embeddedFont>
-      <p:font typeface="Roboto Condensed Black"/>
-      <p:regular r:id="rId201317"/>
-    </p:embeddedFont>
-    <p:embeddedFont>
-      <p:font typeface="Roboto Condensed Bold"/>
-      <p:regular r:id="rId201318"/>
-    </p:embeddedFont>
-    <p:embeddedFont>
-      <p:font typeface="Roboto Condensed"/>
-      <p:regular r:id="rId201319"/>
     </p:embeddedFont>
   </p:embeddedFontLst>
   <p:defaultTextStyle>
@@ -1418,7 +1406,7 @@
           <a:p>
             <a:r>
               <a:rPr lang="en-US" dirty="0"/>
-              <a:t>You fixed a bug in one file and started an unrelated feature in another. Those belong in two commits with two messages, because in six weeks you will want to find the bug fix without dragging the half-finished feature along with it. On a four line program, that choice is meaningless and typing git add feels like busywork. You are not wrong about that today. Ask me again in October.</a:t>
+              <a:t>You fixed a bug in one file and started an unrelated feature in another. Those belong in two commits with two messages, because in six weeks you will want to find the bug fix without dragging the half-finished feature along with it. On a four line program, that choice is meaningless and typing git add feels like busywork. You are not wrong about that today. Ask me again in six weeks.</a:t>
             </a:r>
             <a:endParaRPr lang="en-US" dirty="0"/>
           </a:p>
@@ -1866,7 +1854,7 @@
         </p:blipFill>
         <p:spPr>
           <a:xfrm>
-            <a:off x="0" y="0"/>
+            <a:off x="7619809" y="0"/>
             <a:ext cx="4571886" cy="6858000"/>
           </a:xfrm>
           <a:prstGeom prst="rect">
@@ -1882,7 +1870,7 @@
         </p:nvSpPr>
         <p:spPr>
           <a:xfrm>
-            <a:off x="5233360" y="3072209"/>
+            <a:off x="661475" y="3072209"/>
             <a:ext cx="6296860" cy="590649"/>
           </a:xfrm>
           <a:prstGeom prst="rect">
@@ -1973,7 +1961,7 @@
         </p:nvSpPr>
         <p:spPr>
           <a:xfrm>
-            <a:off x="661475" y="1931194"/>
+            <a:off x="661475" y="1217613"/>
             <a:ext cx="6296860" cy="1181298"/>
           </a:xfrm>
           <a:prstGeom prst="rect">
@@ -2011,14 +1999,41 @@
       </p:sp>
       <p:sp>
         <p:nvSpPr>
-          <p:cNvPr id="4" name="Text 1"/>
-          <p:cNvSpPr/>
-          <p:nvPr/>
-        </p:nvSpPr>
-        <p:spPr>
-          <a:xfrm>
-            <a:off x="661475" y="3395960"/>
-            <a:ext cx="6296860" cy="1407914"/>
+          <p:cNvPr id="4" name="Shape 1"/>
+          <p:cNvSpPr/>
+          <p:nvPr/>
+        </p:nvSpPr>
+        <p:spPr>
+          <a:xfrm>
+            <a:off x="661475" y="2682379"/>
+            <a:ext cx="425241" cy="425252"/>
+          </a:xfrm>
+          <a:prstGeom prst="roundRect">
+            <a:avLst>
+              <a:gd name="adj" fmla="val 18669"/>
+            </a:avLst>
+          </a:prstGeom>
+          <a:solidFill>
+            <a:srgbClr val="D1E5FA"/>
+          </a:solidFill>
+          <a:ln w="19050">
+            <a:solidFill>
+              <a:srgbClr val="B7CBE0"/>
+            </a:solidFill>
+            <a:prstDash val="solid"/>
+          </a:ln>
+        </p:spPr>
+      </p:sp>
+      <p:sp>
+        <p:nvSpPr>
+          <p:cNvPr id="5" name="Text 2"/>
+          <p:cNvSpPr/>
+          <p:nvPr/>
+        </p:nvSpPr>
+        <p:spPr>
+          <a:xfrm>
+            <a:off x="1275723" y="2747268"/>
+            <a:ext cx="5682612" cy="295275"/>
           </a:xfrm>
           <a:prstGeom prst="rect">
             <a:avLst/>
@@ -2027,99 +2042,240 @@
           <a:ln/>
         </p:spPr>
         <p:txBody>
-          <a:bodyPr wrap="square" lIns="0" tIns="75608" rIns="0" bIns="0" rtlCol="0" anchor="t">
-            <a:normAutofit/>
-          </a:bodyPr>
-          <a:lstStyle/>
-          <a:p>
-            <a:pPr algn="l" marL="294640" indent="-294640">
-              <a:lnSpc>
-                <a:spcPct val="133000"/>
-              </a:lnSpc>
-              <a:buSzPct val="100000"/>
-              <a:buChar char="•"/>
-            </a:pPr>
-            <a:r>
-              <a:rPr lang="en-US" sz="1450" dirty="0">
+          <a:bodyPr wrap="none" lIns="0" tIns="0" rIns="0" bIns="0" rtlCol="0" anchor="t"/>
+          <a:lstStyle/>
+          <a:p>
+            <a:pPr algn="l" indent="0" marL="0">
+              <a:lnSpc>
+                <a:spcPct val="104000"/>
+              </a:lnSpc>
+              <a:buNone/>
+            </a:pPr>
+            <a:r>
+              <a:rPr lang="en-US" sz="1850" b="1" dirty="0">
                 <a:solidFill>
                   <a:srgbClr val="1C1C1C"/>
                 </a:solidFill>
-                <a:latin typeface="Roboto Condensed" pitchFamily="34" charset="0"/>
-                <a:ea typeface="Roboto Condensed" pitchFamily="34" charset="-122"/>
-                <a:cs typeface="Roboto Condensed" pitchFamily="34" charset="-120"/>
+                <a:latin typeface="Orbitron Bold" pitchFamily="34" charset="0"/>
+                <a:ea typeface="Orbitron Bold" pitchFamily="34" charset="-122"/>
+                <a:cs typeface="Orbitron Bold" pitchFamily="34" charset="-120"/>
               </a:rPr>
               <a:t>update, fixed, changes: worth nothing</a:t>
             </a:r>
-            <a:endParaRPr lang="en-US" sz="1450" dirty="0"/>
-          </a:p>
-          <a:p>
-            <a:pPr algn="l" marL="294640" indent="-294640">
-              <a:lnSpc>
-                <a:spcPct val="133000"/>
-              </a:lnSpc>
-              <a:buSzPct val="100000"/>
-              <a:buChar char="•"/>
-            </a:pPr>
-            <a:r>
-              <a:rPr lang="en-US" sz="1450" dirty="0">
+            <a:endParaRPr lang="en-US" sz="1850" dirty="0"/>
+          </a:p>
+        </p:txBody>
+      </p:sp>
+      <p:sp>
+        <p:nvSpPr>
+          <p:cNvPr id="6" name="Shape 3"/>
+          <p:cNvSpPr/>
+          <p:nvPr/>
+        </p:nvSpPr>
+        <p:spPr>
+          <a:xfrm>
+            <a:off x="661475" y="3485654"/>
+            <a:ext cx="425241" cy="425252"/>
+          </a:xfrm>
+          <a:prstGeom prst="roundRect">
+            <a:avLst>
+              <a:gd name="adj" fmla="val 18669"/>
+            </a:avLst>
+          </a:prstGeom>
+          <a:solidFill>
+            <a:srgbClr val="D1E5FA"/>
+          </a:solidFill>
+          <a:ln w="19050">
+            <a:solidFill>
+              <a:srgbClr val="B7CBE0"/>
+            </a:solidFill>
+            <a:prstDash val="solid"/>
+          </a:ln>
+        </p:spPr>
+      </p:sp>
+      <p:sp>
+        <p:nvSpPr>
+          <p:cNvPr id="7" name="Text 4"/>
+          <p:cNvSpPr/>
+          <p:nvPr/>
+        </p:nvSpPr>
+        <p:spPr>
+          <a:xfrm>
+            <a:off x="1275723" y="3550543"/>
+            <a:ext cx="5682612" cy="295275"/>
+          </a:xfrm>
+          <a:prstGeom prst="rect">
+            <a:avLst/>
+          </a:prstGeom>
+          <a:noFill/>
+          <a:ln/>
+        </p:spPr>
+        <p:txBody>
+          <a:bodyPr wrap="none" lIns="0" tIns="0" rIns="0" bIns="0" rtlCol="0" anchor="t"/>
+          <a:lstStyle/>
+          <a:p>
+            <a:pPr algn="l" indent="0" marL="0">
+              <a:lnSpc>
+                <a:spcPct val="104000"/>
+              </a:lnSpc>
+              <a:buNone/>
+            </a:pPr>
+            <a:r>
+              <a:rPr lang="en-US" sz="1850" b="1" dirty="0">
                 <a:solidFill>
                   <a:srgbClr val="1C1C1C"/>
                 </a:solidFill>
-                <a:latin typeface="Roboto Condensed" pitchFamily="34" charset="0"/>
-                <a:ea typeface="Roboto Condensed" pitchFamily="34" charset="-122"/>
-                <a:cs typeface="Roboto Condensed" pitchFamily="34" charset="-120"/>
+                <a:latin typeface="Orbitron Bold" pitchFamily="34" charset="0"/>
+                <a:ea typeface="Orbitron Bold" pitchFamily="34" charset="-122"/>
+                <a:cs typeface="Orbitron Bold" pitchFamily="34" charset="-120"/>
               </a:rPr>
               <a:t>The diff already shows what changed</a:t>
             </a:r>
-            <a:endParaRPr lang="en-US" sz="1450" dirty="0"/>
-          </a:p>
-          <a:p>
-            <a:pPr algn="l" marL="294640" indent="-294640">
-              <a:lnSpc>
-                <a:spcPct val="133000"/>
-              </a:lnSpc>
-              <a:buSzPct val="100000"/>
-              <a:buChar char="•"/>
-            </a:pPr>
-            <a:r>
-              <a:rPr lang="en-US" sz="1450" dirty="0">
+            <a:endParaRPr lang="en-US" sz="1850" dirty="0"/>
+          </a:p>
+        </p:txBody>
+      </p:sp>
+      <p:sp>
+        <p:nvSpPr>
+          <p:cNvPr id="8" name="Shape 5"/>
+          <p:cNvSpPr/>
+          <p:nvPr/>
+        </p:nvSpPr>
+        <p:spPr>
+          <a:xfrm>
+            <a:off x="661475" y="4288929"/>
+            <a:ext cx="425241" cy="425252"/>
+          </a:xfrm>
+          <a:prstGeom prst="roundRect">
+            <a:avLst>
+              <a:gd name="adj" fmla="val 18669"/>
+            </a:avLst>
+          </a:prstGeom>
+          <a:solidFill>
+            <a:srgbClr val="D1E5FA"/>
+          </a:solidFill>
+          <a:ln w="19050">
+            <a:solidFill>
+              <a:srgbClr val="B7CBE0"/>
+            </a:solidFill>
+            <a:prstDash val="solid"/>
+          </a:ln>
+        </p:spPr>
+      </p:sp>
+      <p:sp>
+        <p:nvSpPr>
+          <p:cNvPr id="9" name="Text 6"/>
+          <p:cNvSpPr/>
+          <p:nvPr/>
+        </p:nvSpPr>
+        <p:spPr>
+          <a:xfrm>
+            <a:off x="1275723" y="4353818"/>
+            <a:ext cx="5682612" cy="295275"/>
+          </a:xfrm>
+          <a:prstGeom prst="rect">
+            <a:avLst/>
+          </a:prstGeom>
+          <a:noFill/>
+          <a:ln/>
+        </p:spPr>
+        <p:txBody>
+          <a:bodyPr wrap="none" lIns="0" tIns="0" rIns="0" bIns="0" rtlCol="0" anchor="t"/>
+          <a:lstStyle/>
+          <a:p>
+            <a:pPr algn="l" indent="0" marL="0">
+              <a:lnSpc>
+                <a:spcPct val="104000"/>
+              </a:lnSpc>
+              <a:buNone/>
+            </a:pPr>
+            <a:r>
+              <a:rPr lang="en-US" sz="1850" b="1" dirty="0">
                 <a:solidFill>
                   <a:srgbClr val="1C1C1C"/>
                 </a:solidFill>
-                <a:latin typeface="Roboto Condensed" pitchFamily="34" charset="0"/>
-                <a:ea typeface="Roboto Condensed" pitchFamily="34" charset="-122"/>
-                <a:cs typeface="Roboto Condensed" pitchFamily="34" charset="-120"/>
+                <a:latin typeface="Orbitron Bold" pitchFamily="34" charset="0"/>
+                <a:ea typeface="Orbitron Bold" pitchFamily="34" charset="-122"/>
+                <a:cs typeface="Orbitron Bold" pitchFamily="34" charset="-120"/>
               </a:rPr>
               <a:t>Your message is the only record of why</a:t>
             </a:r>
-            <a:endParaRPr lang="en-US" sz="1450" dirty="0"/>
-          </a:p>
-          <a:p>
-            <a:pPr algn="l" marL="294640" indent="-294640">
-              <a:lnSpc>
-                <a:spcPct val="133000"/>
-              </a:lnSpc>
-              <a:buSzPct val="100000"/>
-              <a:buChar char="•"/>
-            </a:pPr>
-            <a:r>
-              <a:rPr lang="en-US" sz="1450" dirty="0">
+            <a:endParaRPr lang="en-US" sz="1850" dirty="0"/>
+          </a:p>
+        </p:txBody>
+      </p:sp>
+      <p:sp>
+        <p:nvSpPr>
+          <p:cNvPr id="10" name="Shape 7"/>
+          <p:cNvSpPr/>
+          <p:nvPr/>
+        </p:nvSpPr>
+        <p:spPr>
+          <a:xfrm>
+            <a:off x="661475" y="5092204"/>
+            <a:ext cx="425241" cy="425252"/>
+          </a:xfrm>
+          <a:prstGeom prst="roundRect">
+            <a:avLst>
+              <a:gd name="adj" fmla="val 18669"/>
+            </a:avLst>
+          </a:prstGeom>
+          <a:solidFill>
+            <a:srgbClr val="D1E5FA"/>
+          </a:solidFill>
+          <a:ln w="19050">
+            <a:solidFill>
+              <a:srgbClr val="B7CBE0"/>
+            </a:solidFill>
+            <a:prstDash val="solid"/>
+          </a:ln>
+        </p:spPr>
+      </p:sp>
+      <p:sp>
+        <p:nvSpPr>
+          <p:cNvPr id="11" name="Text 8"/>
+          <p:cNvSpPr/>
+          <p:nvPr/>
+        </p:nvSpPr>
+        <p:spPr>
+          <a:xfrm>
+            <a:off x="1275723" y="5157093"/>
+            <a:ext cx="5682612" cy="295275"/>
+          </a:xfrm>
+          <a:prstGeom prst="rect">
+            <a:avLst/>
+          </a:prstGeom>
+          <a:noFill/>
+          <a:ln/>
+        </p:spPr>
+        <p:txBody>
+          <a:bodyPr wrap="none" lIns="0" tIns="0" rIns="0" bIns="0" rtlCol="0" anchor="t"/>
+          <a:lstStyle/>
+          <a:p>
+            <a:pPr algn="l" indent="0" marL="0">
+              <a:lnSpc>
+                <a:spcPct val="104000"/>
+              </a:lnSpc>
+              <a:buNone/>
+            </a:pPr>
+            <a:r>
+              <a:rPr lang="en-US" sz="1850" b="1" dirty="0">
                 <a:solidFill>
                   <a:srgbClr val="1C1C1C"/>
                 </a:solidFill>
-                <a:latin typeface="Roboto Condensed" pitchFamily="34" charset="0"/>
-                <a:ea typeface="Roboto Condensed" pitchFamily="34" charset="-122"/>
-                <a:cs typeface="Roboto Condensed" pitchFamily="34" charset="-120"/>
+                <a:latin typeface="Orbitron Bold" pitchFamily="34" charset="0"/>
+                <a:ea typeface="Orbitron Bold" pitchFamily="34" charset="-122"/>
+                <a:cs typeface="Orbitron Bold" pitchFamily="34" charset="-120"/>
               </a:rPr>
               <a:t>Complete this: "This commit will..."</a:t>
             </a:r>
-            <a:endParaRPr lang="en-US" sz="1450" dirty="0"/>
-          </a:p>
-        </p:txBody>
-      </p:sp>
-      <p:sp>
-        <p:nvSpPr>
-          <p:cNvPr id="5" name="Text 2"/>
+            <a:endParaRPr lang="en-US" sz="1850" dirty="0"/>
+          </a:p>
+        </p:txBody>
+      </p:sp>
+      <p:sp>
+        <p:nvSpPr>
+          <p:cNvPr id="12" name="Text 9"/>
           <p:cNvSpPr/>
           <p:nvPr/>
         </p:nvSpPr>
@@ -2135,7 +2291,7 @@
           <a:ln/>
         </p:spPr>
         <p:txBody>
-          <a:bodyPr wrap="none" lIns="0" tIns="99235" rIns="59541" bIns="0" rtlCol="0" anchor="t"/>
+          <a:bodyPr wrap="none" lIns="99235" tIns="0" rIns="59541" bIns="0" rtlCol="0" anchor="t"/>
           <a:lstStyle/>
           <a:p>
             <a:pPr algn="l" indent="0" marL="0">
@@ -2200,8 +2356,8 @@
         </p:blipFill>
         <p:spPr>
           <a:xfrm>
-            <a:off x="0" y="0"/>
-            <a:ext cx="4571886" cy="6858000"/>
+            <a:off x="661475" y="1411585"/>
+            <a:ext cx="6903269" cy="3911898"/>
           </a:xfrm>
           <a:prstGeom prst="rect">
             <a:avLst/>
@@ -2216,8 +2372,8 @@
         </p:nvSpPr>
         <p:spPr>
           <a:xfrm>
-            <a:off x="5233360" y="1931194"/>
-            <a:ext cx="6296860" cy="1181298"/>
+            <a:off x="8032251" y="1442145"/>
+            <a:ext cx="3504219" cy="1771948"/>
           </a:xfrm>
           <a:prstGeom prst="rect">
             <a:avLst/>
@@ -2260,8 +2416,8 @@
         </p:nvSpPr>
         <p:spPr>
           <a:xfrm>
-            <a:off x="5233360" y="3395960"/>
-            <a:ext cx="6296860" cy="1407914"/>
+            <a:off x="8032251" y="3403104"/>
+            <a:ext cx="3504219" cy="2012752"/>
           </a:xfrm>
           <a:prstGeom prst="rect">
             <a:avLst/>
@@ -2270,7 +2426,7 @@
           <a:ln/>
         </p:spPr>
         <p:txBody>
-          <a:bodyPr wrap="square" lIns="0" tIns="75608" rIns="0" bIns="0" rtlCol="0" anchor="t">
+          <a:bodyPr wrap="square" lIns="0" tIns="0" rIns="0" bIns="0" rtlCol="0" anchor="t">
             <a:normAutofit/>
           </a:bodyPr>
           <a:lstStyle/>
@@ -2368,7 +2524,7 @@
         </p:nvSpPr>
         <p:spPr>
           <a:xfrm>
-            <a:off x="4704141" y="6457255"/>
+            <a:off x="132255" y="6457255"/>
             <a:ext cx="3640642" cy="158750"/>
           </a:xfrm>
           <a:prstGeom prst="rect">
@@ -2378,7 +2534,7 @@
           <a:ln/>
         </p:spPr>
         <p:txBody>
-          <a:bodyPr wrap="none" lIns="0" tIns="99235" rIns="59541" bIns="0" rtlCol="0" anchor="t"/>
+          <a:bodyPr wrap="none" lIns="99235" tIns="0" rIns="59541" bIns="0" rtlCol="0" anchor="t"/>
           <a:lstStyle/>
           <a:p>
             <a:pPr algn="l" indent="0" marL="0">
@@ -2513,7 +2669,7 @@
           <a:ln/>
         </p:spPr>
         <p:txBody>
-          <a:bodyPr wrap="square" lIns="0" tIns="75608" rIns="0" bIns="0" rtlCol="0" anchor="t">
+          <a:bodyPr wrap="square" lIns="0" tIns="0" rIns="0" bIns="0" rtlCol="0" anchor="t">
             <a:normAutofit/>
           </a:bodyPr>
           <a:lstStyle/>
@@ -2621,7 +2777,7 @@
           <a:ln/>
         </p:spPr>
         <p:txBody>
-          <a:bodyPr wrap="none" lIns="0" tIns="99235" rIns="59541" bIns="0" rtlCol="0" anchor="t"/>
+          <a:bodyPr wrap="none" lIns="99235" tIns="0" rIns="59541" bIns="0" rtlCol="0" anchor="t"/>
           <a:lstStyle/>
           <a:p>
             <a:pPr algn="l" indent="0" marL="0">
@@ -2756,7 +2912,7 @@
           <a:ln/>
         </p:spPr>
         <p:txBody>
-          <a:bodyPr wrap="square" lIns="0" tIns="75608" rIns="0" bIns="0" rtlCol="0" anchor="t">
+          <a:bodyPr wrap="square" lIns="0" tIns="0" rIns="0" bIns="0" rtlCol="0" anchor="t">
             <a:normAutofit/>
           </a:bodyPr>
           <a:lstStyle/>
@@ -2864,7 +3020,7 @@
           <a:ln/>
         </p:spPr>
         <p:txBody>
-          <a:bodyPr wrap="none" lIns="0" tIns="99235" rIns="59541" bIns="0" rtlCol="0" anchor="t"/>
+          <a:bodyPr wrap="none" lIns="99235" tIns="0" rIns="59541" bIns="0" rtlCol="0" anchor="t"/>
           <a:lstStyle/>
           <a:p>
             <a:pPr algn="l" indent="0" marL="0">
@@ -3275,7 +3431,7 @@
           <a:ln/>
         </p:spPr>
         <p:txBody>
-          <a:bodyPr wrap="none" lIns="0" tIns="99235" rIns="59541" bIns="0" rtlCol="0" anchor="t"/>
+          <a:bodyPr wrap="none" lIns="99235" tIns="0" rIns="59541" bIns="0" rtlCol="0" anchor="t"/>
           <a:lstStyle/>
           <a:p>
             <a:pPr algn="l" indent="0" marL="0">
@@ -3530,7 +3686,7 @@
           <a:ln/>
         </p:spPr>
         <p:txBody>
-          <a:bodyPr wrap="none" lIns="0" tIns="99235" rIns="59541" bIns="0" rtlCol="0" anchor="t"/>
+          <a:bodyPr wrap="none" lIns="99235" tIns="0" rIns="59541" bIns="0" rtlCol="0" anchor="t"/>
           <a:lstStyle/>
           <a:p>
             <a:pPr algn="l" indent="0" marL="0">
@@ -3832,7 +3988,7 @@
           <a:ln/>
         </p:spPr>
         <p:txBody>
-          <a:bodyPr wrap="none" lIns="0" tIns="99235" rIns="59541" bIns="0" rtlCol="0" anchor="t"/>
+          <a:bodyPr wrap="none" lIns="99235" tIns="0" rIns="59541" bIns="0" rtlCol="0" anchor="t"/>
           <a:lstStyle/>
           <a:p>
             <a:pPr algn="l" indent="0" marL="0">
@@ -3967,7 +4123,7 @@
           <a:ln/>
         </p:spPr>
         <p:txBody>
-          <a:bodyPr wrap="square" lIns="0" tIns="75608" rIns="0" bIns="0" rtlCol="0" anchor="t">
+          <a:bodyPr wrap="square" lIns="0" tIns="0" rIns="0" bIns="0" rtlCol="0" anchor="t">
             <a:normAutofit/>
           </a:bodyPr>
           <a:lstStyle/>
@@ -4075,7 +4231,7 @@
           <a:ln/>
         </p:spPr>
         <p:txBody>
-          <a:bodyPr wrap="none" lIns="0" tIns="99235" rIns="59541" bIns="0" rtlCol="0" anchor="t"/>
+          <a:bodyPr wrap="none" lIns="99235" tIns="0" rIns="59541" bIns="0" rtlCol="0" anchor="t"/>
           <a:lstStyle/>
           <a:p>
             <a:pPr algn="l" indent="0" marL="0">
@@ -4496,7 +4652,7 @@
           <a:ln/>
         </p:spPr>
         <p:txBody>
-          <a:bodyPr wrap="none" lIns="0" tIns="99235" rIns="59541" bIns="0" rtlCol="0" anchor="t"/>
+          <a:bodyPr wrap="none" lIns="99235" tIns="0" rIns="59541" bIns="0" rtlCol="0" anchor="t"/>
           <a:lstStyle/>
           <a:p>
             <a:pPr algn="l" indent="0" marL="0">
@@ -4577,8 +4733,8 @@
         </p:nvSpPr>
         <p:spPr>
           <a:xfrm>
-            <a:off x="5123149" y="4187249"/>
-            <a:ext cx="1280885" cy="246752"/>
+            <a:off x="5123149" y="4063874"/>
+            <a:ext cx="1280885" cy="493504"/>
           </a:xfrm>
           <a:prstGeom prst="rect">
             <a:avLst/>
@@ -4587,7 +4743,9 @@
           <a:ln/>
         </p:spPr>
         <p:txBody>
-          <a:bodyPr wrap="none" lIns="0" tIns="0" rIns="0" bIns="0" rtlCol="0" anchor="t"/>
+          <a:bodyPr wrap="square" lIns="0" tIns="0" rIns="0" bIns="0" rtlCol="0" anchor="t">
+            <a:normAutofit/>
+          </a:bodyPr>
           <a:lstStyle/>
           <a:p>
             <a:pPr algn="ctr" indent="0" marL="0">
@@ -4605,7 +4763,7 @@
                 <a:ea typeface="Orbitron Bold" pitchFamily="34" charset="-122"/>
                 <a:cs typeface="Orbitron Bold" pitchFamily="34" charset="-120"/>
               </a:rPr>
-              <a:t>Repository</a:t>
+              <a:t>Commit History</a:t>
             </a:r>
             <a:endParaRPr lang="en-US" sz="1550" dirty="0"/>
           </a:p>
@@ -4663,8 +4821,8 @@
         </p:nvSpPr>
         <p:spPr>
           <a:xfrm>
-            <a:off x="1868297" y="4187249"/>
-            <a:ext cx="1280885" cy="246752"/>
+            <a:off x="1868297" y="4063874"/>
+            <a:ext cx="1280885" cy="493504"/>
           </a:xfrm>
           <a:prstGeom prst="rect">
             <a:avLst/>
@@ -4673,7 +4831,9 @@
           <a:ln/>
         </p:spPr>
         <p:txBody>
-          <a:bodyPr wrap="none" lIns="0" tIns="0" rIns="0" bIns="0" rtlCol="0" anchor="t"/>
+          <a:bodyPr wrap="square" lIns="0" tIns="0" rIns="0" bIns="0" rtlCol="0" anchor="t">
+            <a:normAutofit/>
+          </a:bodyPr>
           <a:lstStyle/>
           <a:p>
             <a:pPr algn="ctr" indent="0" marL="0">
@@ -4691,7 +4851,7 @@
                 <a:ea typeface="Orbitron Bold" pitchFamily="34" charset="-122"/>
                 <a:cs typeface="Orbitron Bold" pitchFamily="34" charset="-120"/>
               </a:rPr>
-              <a:t>Working Dir</a:t>
+              <a:t>Working Files</a:t>
             </a:r>
             <a:endParaRPr lang="en-US" sz="1550" dirty="0"/>
           </a:p>
@@ -4759,7 +4919,7 @@
           <a:ln/>
         </p:spPr>
         <p:txBody>
-          <a:bodyPr wrap="square" lIns="0" tIns="75608" rIns="0" bIns="0" rtlCol="0" anchor="t">
+          <a:bodyPr wrap="square" lIns="0" tIns="0" rIns="0" bIns="0" rtlCol="0" anchor="t">
             <a:normAutofit/>
           </a:bodyPr>
           <a:lstStyle/>
@@ -4867,7 +5027,7 @@
           <a:ln/>
         </p:spPr>
         <p:txBody>
-          <a:bodyPr wrap="none" lIns="0" tIns="99235" rIns="59541" bIns="0" rtlCol="0" anchor="t"/>
+          <a:bodyPr wrap="none" lIns="99235" tIns="0" rIns="59541" bIns="0" rtlCol="0" anchor="t"/>
           <a:lstStyle/>
           <a:p>
             <a:pPr algn="l" indent="0" marL="0">

</xml_diff>